<commit_message>
meetings/2026-07-06: add force-decode-vs-ship fact-check slide
New slide after 'where to reuse': the breakeven table (KV-move regime / move-per-warm-token /
B-wins-when across ~15 MB/s .. ~4 GB/s) plus the enabling numbers and how they are derived
(t_dec 446 / t_pf 170 us -> penalty 276 us; KV 112 KB/token; R* = d*BW/B) and the chat scenario.
Deck now 7 slides.
</commit_message>
<xml_diff>
--- a/projects/WaferEngine-staging/meetings/2026-07-06.pptx
+++ b/projects/WaferEngine-staging/meetings/2026-07-06.pptx
@@ -11,6 +11,7 @@
     <p:sldId id="259" r:id="rId10"/>
     <p:sldId id="260" r:id="rId11"/>
     <p:sldId id="261" r:id="rId12"/>
+    <p:sldId id="262" r:id="rId13"/>
   </p:sldIdLst>
   <p:sldSz cx="12191695" cy="6858000" type="screen4x3"/>
   <p:notesSz cx="6858000" cy="9144000"/>
@@ -7650,6 +7651,771 @@
                 </a:solidFill>
                 <a:latin typeface="Aptos"/>
               </a:rPr>
+              <a:t>When does “force-decode in place” (B) beat “ship to prefill” (A)?</a:t>
+            </a:r>
+          </a:p>
+        </p:txBody>
+      </p:sp>
+      <p:sp>
+        <p:nvSpPr>
+          <p:cNvPr id="4" name="Rounded Rectangle 3"/>
+          <p:cNvSpPr/>
+          <p:nvPr/>
+        </p:nvSpPr>
+        <p:spPr>
+          <a:xfrm>
+            <a:off x="457200" y="1078992"/>
+            <a:ext cx="4160520" cy="457200"/>
+          </a:xfrm>
+          <a:prstGeom prst="roundRect">
+            <a:avLst/>
+          </a:prstGeom>
+          <a:solidFill>
+            <a:srgbClr val="2E6DB4"/>
+          </a:solidFill>
+          <a:ln>
+            <a:noFill/>
+          </a:ln>
+          <a:effectLst/>
+        </p:spPr>
+        <p:style>
+          <a:lnRef idx="1">
+            <a:schemeClr val="accent1"/>
+          </a:lnRef>
+          <a:fillRef idx="3">
+            <a:schemeClr val="accent1"/>
+          </a:fillRef>
+          <a:effectRef idx="2">
+            <a:schemeClr val="accent1"/>
+          </a:effectRef>
+          <a:fontRef idx="minor">
+            <a:schemeClr val="lt1"/>
+          </a:fontRef>
+        </p:style>
+        <p:txBody>
+          <a:bodyPr rtlCol="0" anchor="ctr" wrap="square" lIns="50800" rIns="50800" tIns="25400" bIns="25400"/>
+          <a:lstStyle/>
+          <a:p>
+            <a:pPr algn="ctr"/>
+            <a:r>
+              <a:rPr sz="1300" b="1">
+                <a:solidFill>
+                  <a:srgbClr val="FFFFFF"/>
+                </a:solidFill>
+                <a:latin typeface="Aptos"/>
+              </a:rPr>
+              <a:t>The numbers  —  same e2e device run</a:t>
+            </a:r>
+          </a:p>
+        </p:txBody>
+      </p:sp>
+      <p:sp>
+        <p:nvSpPr>
+          <p:cNvPr id="5" name="TextBox 4"/>
+          <p:cNvSpPr txBox="1"/>
+          <p:nvPr/>
+        </p:nvSpPr>
+        <p:spPr>
+          <a:xfrm>
+            <a:off x="502920" y="1627631"/>
+            <a:ext cx="4142232" cy="4297680"/>
+          </a:xfrm>
+          <a:prstGeom prst="rect">
+            <a:avLst/>
+          </a:prstGeom>
+          <a:noFill/>
+        </p:spPr>
+        <p:txBody>
+          <a:bodyPr wrap="square" anchor="t">
+            <a:spAutoFit/>
+          </a:bodyPr>
+          <a:lstStyle/>
+          <a:p>
+            <a:pPr>
+              <a:spcBef>
+                <a:spcPts val="0"/>
+              </a:spcBef>
+              <a:spcAft>
+                <a:spcPts val="600"/>
+              </a:spcAft>
+            </a:pPr>
+            <a:r>
+              <a:rPr sz="1300" b="0">
+                <a:solidFill>
+                  <a:srgbClr val="242E3A"/>
+                </a:solidFill>
+                <a:latin typeface="Aptos"/>
+              </a:rPr>
+              <a:t>•  Decode 446 µs/token  ·  Prefill 170 µs/token (amortized)</a:t>
+            </a:r>
+          </a:p>
+          <a:p>
+            <a:pPr>
+              <a:spcBef>
+                <a:spcPts val="0"/>
+              </a:spcBef>
+              <a:spcAft>
+                <a:spcPts val="600"/>
+              </a:spcAft>
+            </a:pPr>
+            <a:r>
+              <a:rPr sz="1200" b="0">
+                <a:solidFill>
+                  <a:srgbClr val="5B6B7B"/>
+                </a:solidFill>
+                <a:latin typeface="Aptos"/>
+              </a:rPr>
+              <a:t>    –  → only ~2.6× apart (weights sit in SRAM)</a:t>
+            </a:r>
+          </a:p>
+          <a:p>
+            <a:pPr>
+              <a:spcBef>
+                <a:spcPts val="0"/>
+              </a:spcBef>
+              <a:spcAft>
+                <a:spcPts val="600"/>
+              </a:spcAft>
+            </a:pPr>
+            <a:r>
+              <a:rPr sz="1300" b="1">
+                <a:solidFill>
+                  <a:srgbClr val="242E3A"/>
+                </a:solidFill>
+                <a:latin typeface="Aptos"/>
+              </a:rPr>
+              <a:t>•  Force-decode penalty:</a:t>
+            </a:r>
+          </a:p>
+          <a:p>
+            <a:pPr>
+              <a:spcBef>
+                <a:spcPts val="0"/>
+              </a:spcBef>
+              <a:spcAft>
+                <a:spcPts val="600"/>
+              </a:spcAft>
+            </a:pPr>
+            <a:r>
+              <a:rPr sz="1300" b="1">
+                <a:solidFill>
+                  <a:srgbClr val="C77A1E"/>
+                </a:solidFill>
+                <a:latin typeface="Aptos"/>
+              </a:rPr>
+              <a:t>    –  Δ = 446 − 170 = 276 µs per new token</a:t>
+            </a:r>
+          </a:p>
+          <a:p>
+            <a:pPr>
+              <a:spcBef>
+                <a:spcPts val="0"/>
+              </a:spcBef>
+              <a:spcAft>
+                <a:spcPts val="600"/>
+              </a:spcAft>
+            </a:pPr>
+            <a:r>
+              <a:rPr sz="1300" b="0">
+                <a:solidFill>
+                  <a:srgbClr val="242E3A"/>
+                </a:solidFill>
+                <a:latin typeface="Aptos"/>
+              </a:rPr>
+              <a:t>•  KV size  B = 112 KB / token</a:t>
+            </a:r>
+          </a:p>
+          <a:p>
+            <a:pPr>
+              <a:spcBef>
+                <a:spcPts val="0"/>
+              </a:spcBef>
+              <a:spcAft>
+                <a:spcPts val="600"/>
+              </a:spcAft>
+            </a:pPr>
+            <a:r>
+              <a:rPr sz="1100" b="0">
+                <a:solidFill>
+                  <a:srgbClr val="5B6B7B"/>
+                </a:solidFill>
+                <a:latin typeface="Aptos"/>
+              </a:rPr>
+              <a:t>    –  (28 layers × 8 kv-heads × 128 × 2)</a:t>
+            </a:r>
+          </a:p>
+          <a:p>
+            <a:pPr>
+              <a:spcBef>
+                <a:spcPts val="0"/>
+              </a:spcBef>
+              <a:spcAft>
+                <a:spcPts val="600"/>
+              </a:spcAft>
+            </a:pPr>
+            <a:r>
+              <a:rPr sz="1300" b="0">
+                <a:solidFill>
+                  <a:srgbClr val="242E3A"/>
+                </a:solidFill>
+                <a:latin typeface="Aptos"/>
+              </a:rPr>
+              <a:t>•  Move time per warm token:  m = B ÷ bandwidth</a:t>
+            </a:r>
+          </a:p>
+          <a:p>
+            <a:pPr>
+              <a:spcBef>
+                <a:spcPts val="0"/>
+              </a:spcBef>
+              <a:spcAft>
+                <a:spcPts val="600"/>
+              </a:spcAft>
+            </a:pPr>
+            <a:r>
+              <a:rPr sz="1300" b="1">
+                <a:solidFill>
+                  <a:srgbClr val="2E8B57"/>
+                </a:solidFill>
+                <a:latin typeface="Aptos"/>
+              </a:rPr>
+              <a:t>•  Break-even — B wins when:</a:t>
+            </a:r>
+          </a:p>
+          <a:p>
+            <a:pPr>
+              <a:spcBef>
+                <a:spcPts val="0"/>
+              </a:spcBef>
+              <a:spcAft>
+                <a:spcPts val="600"/>
+              </a:spcAft>
+            </a:pPr>
+            <a:r>
+              <a:rPr sz="1350" b="1">
+                <a:solidFill>
+                  <a:srgbClr val="2E8B57"/>
+                </a:solidFill>
+                <a:latin typeface="Aptos"/>
+              </a:rPr>
+              <a:t>    –  L_history / L_new  &gt;  Δ · BW / B   ≡  R*</a:t>
+            </a:r>
+          </a:p>
+        </p:txBody>
+      </p:sp>
+      <p:graphicFrame>
+        <p:nvGraphicFramePr>
+          <p:cNvPr id="6" name="Table 5"/>
+          <p:cNvGraphicFramePr>
+            <a:graphicFrameLocks noGrp="1"/>
+          </p:cNvGraphicFramePr>
+          <p:nvPr/>
+        </p:nvGraphicFramePr>
+        <p:xfrm>
+          <a:off x="4892040" y="1188720"/>
+          <a:ext cx="6812280" cy="2697480"/>
+        </p:xfrm>
+        <a:graphic>
+          <a:graphicData uri="http://schemas.openxmlformats.org/drawingml/2006/table">
+            <a:tbl>
+              <a:tblPr firstRow="1" bandRow="1">
+                <a:tableStyleId>{5C22544A-7EE6-4342-B048-85BDC9FD1C3A}</a:tableStyleId>
+              </a:tblPr>
+              <a:tblGrid>
+                <a:gridCol w="2788920"/>
+                <a:gridCol w="1417320"/>
+                <a:gridCol w="2606040"/>
+              </a:tblGrid>
+              <a:tr h="674370">
+                <a:tc>
+                  <a:txBody>
+                    <a:bodyPr wrap="square"/>
+                    <a:lstStyle/>
+                    <a:p>
+                      <a:r>
+                        <a:rPr sz="1200" b="1">
+                          <a:solidFill>
+                            <a:srgbClr val="FFFFFF"/>
+                          </a:solidFill>
+                          <a:latin typeface="Aptos"/>
+                        </a:rPr>
+                        <a:t>KV-move regime (effective BW)</a:t>
+                      </a:r>
+                    </a:p>
+                  </a:txBody>
+                  <a:tcPr anchor="ctr" marL="88900" marR="76200" marT="38100" marB="38100">
+                    <a:solidFill>
+                      <a:srgbClr val="1F3A5F"/>
+                    </a:solidFill>
+                  </a:tcPr>
+                </a:tc>
+                <a:tc>
+                  <a:txBody>
+                    <a:bodyPr wrap="square"/>
+                    <a:lstStyle/>
+                    <a:p>
+                      <a:r>
+                        <a:rPr sz="1200" b="1">
+                          <a:solidFill>
+                            <a:srgbClr val="FFFFFF"/>
+                          </a:solidFill>
+                          <a:latin typeface="Aptos"/>
+                        </a:rPr>
+                        <a:t>move /</a:t>
+                      </a:r>
+                    </a:p>
+                    <a:p>
+                      <a:r>
+                        <a:rPr sz="1200" b="1">
+                          <a:solidFill>
+                            <a:srgbClr val="FFFFFF"/>
+                          </a:solidFill>
+                          <a:latin typeface="Aptos"/>
+                        </a:rPr>
+                        <a:t>warm-token</a:t>
+                      </a:r>
+                    </a:p>
+                  </a:txBody>
+                  <a:tcPr anchor="ctr" marL="88900" marR="76200" marT="38100" marB="38100">
+                    <a:solidFill>
+                      <a:srgbClr val="1F3A5F"/>
+                    </a:solidFill>
+                  </a:tcPr>
+                </a:tc>
+                <a:tc>
+                  <a:txBody>
+                    <a:bodyPr wrap="square"/>
+                    <a:lstStyle/>
+                    <a:p>
+                      <a:r>
+                        <a:rPr sz="1200" b="1">
+                          <a:solidFill>
+                            <a:srgbClr val="FFFFFF"/>
+                          </a:solidFill>
+                          <a:latin typeface="Aptos"/>
+                        </a:rPr>
+                        <a:t>Force-decode (B) wins when</a:t>
+                      </a:r>
+                    </a:p>
+                  </a:txBody>
+                  <a:tcPr anchor="ctr" marL="88900" marR="76200" marT="38100" marB="38100">
+                    <a:solidFill>
+                      <a:srgbClr val="1F3A5F"/>
+                    </a:solidFill>
+                  </a:tcPr>
+                </a:tc>
+              </a:tr>
+              <a:tr h="674370">
+                <a:tc>
+                  <a:txBody>
+                    <a:bodyPr wrap="square"/>
+                    <a:lstStyle/>
+                    <a:p>
+                      <a:r>
+                        <a:rPr sz="1250">
+                          <a:solidFill>
+                            <a:srgbClr val="242E3A"/>
+                          </a:solidFill>
+                          <a:latin typeface="Aptos"/>
+                        </a:rPr>
+                        <a:t>current single-stream  (~15 MB/s)</a:t>
+                      </a:r>
+                    </a:p>
+                  </a:txBody>
+                  <a:tcPr anchor="ctr" marL="88900" marR="76200" marT="38100" marB="38100">
+                    <a:solidFill>
+                      <a:srgbClr val="FFFFFF"/>
+                    </a:solidFill>
+                  </a:tcPr>
+                </a:tc>
+                <a:tc>
+                  <a:txBody>
+                    <a:bodyPr wrap="square"/>
+                    <a:lstStyle/>
+                    <a:p>
+                      <a:r>
+                        <a:rPr sz="1250" b="1">
+                          <a:solidFill>
+                            <a:srgbClr val="242E3A"/>
+                          </a:solidFill>
+                          <a:latin typeface="Aptos"/>
+                        </a:rPr>
+                        <a:t>~7800 µs</a:t>
+                      </a:r>
+                    </a:p>
+                  </a:txBody>
+                  <a:tcPr anchor="ctr" marL="88900" marR="76200" marT="38100" marB="38100">
+                    <a:solidFill>
+                      <a:srgbClr val="FFFFFF"/>
+                    </a:solidFill>
+                  </a:tcPr>
+                </a:tc>
+                <a:tc>
+                  <a:txBody>
+                    <a:bodyPr wrap="square"/>
+                    <a:lstStyle/>
+                    <a:p>
+                      <a:r>
+                        <a:rPr sz="1250" b="1">
+                          <a:solidFill>
+                            <a:srgbClr val="2E8B57"/>
+                          </a:solidFill>
+                          <a:latin typeface="Aptos"/>
+                        </a:rPr>
+                        <a:t>L_hist / L_new &gt; 0.035</a:t>
+                      </a:r>
+                    </a:p>
+                    <a:p>
+                      <a:r>
+                        <a:rPr sz="1250" b="0">
+                          <a:solidFill>
+                            <a:srgbClr val="2E8B57"/>
+                          </a:solidFill>
+                          <a:latin typeface="Aptos"/>
+                        </a:rPr>
+                        <a:t>→ almost always</a:t>
+                      </a:r>
+                    </a:p>
+                  </a:txBody>
+                  <a:tcPr anchor="ctr" marL="88900" marR="76200" marT="38100" marB="38100">
+                    <a:solidFill>
+                      <a:srgbClr val="FFFFFF"/>
+                    </a:solidFill>
+                  </a:tcPr>
+                </a:tc>
+              </a:tr>
+              <a:tr h="674370">
+                <a:tc>
+                  <a:txBody>
+                    <a:bodyPr wrap="square"/>
+                    <a:lstStyle/>
+                    <a:p>
+                      <a:r>
+                        <a:rPr sz="1250">
+                          <a:solidFill>
+                            <a:srgbClr val="242E3A"/>
+                          </a:solidFill>
+                          <a:latin typeface="Aptos"/>
+                        </a:rPr>
+                        <a:t>optimized multi-stream  (~1 GB/s)</a:t>
+                      </a:r>
+                    </a:p>
+                  </a:txBody>
+                  <a:tcPr anchor="ctr" marL="88900" marR="76200" marT="38100" marB="38100">
+                    <a:solidFill>
+                      <a:srgbClr val="F1F5F9"/>
+                    </a:solidFill>
+                  </a:tcPr>
+                </a:tc>
+                <a:tc>
+                  <a:txBody>
+                    <a:bodyPr wrap="square"/>
+                    <a:lstStyle/>
+                    <a:p>
+                      <a:r>
+                        <a:rPr sz="1250" b="1">
+                          <a:solidFill>
+                            <a:srgbClr val="242E3A"/>
+                          </a:solidFill>
+                          <a:latin typeface="Aptos"/>
+                        </a:rPr>
+                        <a:t>~115 µs</a:t>
+                      </a:r>
+                    </a:p>
+                  </a:txBody>
+                  <a:tcPr anchor="ctr" marL="88900" marR="76200" marT="38100" marB="38100">
+                    <a:solidFill>
+                      <a:srgbClr val="F1F5F9"/>
+                    </a:solidFill>
+                  </a:tcPr>
+                </a:tc>
+                <a:tc>
+                  <a:txBody>
+                    <a:bodyPr wrap="square"/>
+                    <a:lstStyle/>
+                    <a:p>
+                      <a:r>
+                        <a:rPr sz="1250" b="1">
+                          <a:solidFill>
+                            <a:srgbClr val="2E8B57"/>
+                          </a:solidFill>
+                          <a:latin typeface="Aptos"/>
+                        </a:rPr>
+                        <a:t>L_hist / L_new &gt; 2.4</a:t>
+                      </a:r>
+                    </a:p>
+                    <a:p>
+                      <a:r>
+                        <a:rPr sz="1250" b="0">
+                          <a:solidFill>
+                            <a:srgbClr val="2E8B57"/>
+                          </a:solidFill>
+                          <a:latin typeface="Aptos"/>
+                        </a:rPr>
+                        <a:t>→ typical chat</a:t>
+                      </a:r>
+                    </a:p>
+                  </a:txBody>
+                  <a:tcPr anchor="ctr" marL="88900" marR="76200" marT="38100" marB="38100">
+                    <a:solidFill>
+                      <a:srgbClr val="F1F5F9"/>
+                    </a:solidFill>
+                  </a:tcPr>
+                </a:tc>
+              </a:tr>
+              <a:tr h="674370">
+                <a:tc>
+                  <a:txBody>
+                    <a:bodyPr wrap="square"/>
+                    <a:lstStyle/>
+                    <a:p>
+                      <a:r>
+                        <a:rPr sz="1250">
+                          <a:solidFill>
+                            <a:srgbClr val="242E3A"/>
+                          </a:solidFill>
+                          <a:latin typeface="Aptos"/>
+                        </a:rPr>
+                        <a:t>ideal 4-ch RoCE  (~4 GB/s)</a:t>
+                      </a:r>
+                    </a:p>
+                  </a:txBody>
+                  <a:tcPr anchor="ctr" marL="88900" marR="76200" marT="38100" marB="38100">
+                    <a:solidFill>
+                      <a:srgbClr val="FFFFFF"/>
+                    </a:solidFill>
+                  </a:tcPr>
+                </a:tc>
+                <a:tc>
+                  <a:txBody>
+                    <a:bodyPr wrap="square"/>
+                    <a:lstStyle/>
+                    <a:p>
+                      <a:r>
+                        <a:rPr sz="1250" b="1">
+                          <a:solidFill>
+                            <a:srgbClr val="242E3A"/>
+                          </a:solidFill>
+                          <a:latin typeface="Aptos"/>
+                        </a:rPr>
+                        <a:t>~29 µs</a:t>
+                      </a:r>
+                    </a:p>
+                  </a:txBody>
+                  <a:tcPr anchor="ctr" marL="88900" marR="76200" marT="38100" marB="38100">
+                    <a:solidFill>
+                      <a:srgbClr val="FFFFFF"/>
+                    </a:solidFill>
+                  </a:tcPr>
+                </a:tc>
+                <a:tc>
+                  <a:txBody>
+                    <a:bodyPr wrap="square"/>
+                    <a:lstStyle/>
+                    <a:p>
+                      <a:r>
+                        <a:rPr sz="1250" b="1">
+                          <a:solidFill>
+                            <a:srgbClr val="2E8B57"/>
+                          </a:solidFill>
+                          <a:latin typeface="Aptos"/>
+                        </a:rPr>
+                        <a:t>L_hist / L_new &gt; 9.6</a:t>
+                      </a:r>
+                    </a:p>
+                    <a:p>
+                      <a:r>
+                        <a:rPr sz="1250" b="0">
+                          <a:solidFill>
+                            <a:srgbClr val="2E8B57"/>
+                          </a:solidFill>
+                          <a:latin typeface="Aptos"/>
+                        </a:rPr>
+                        <a:t>→ long chats</a:t>
+                      </a:r>
+                    </a:p>
+                  </a:txBody>
+                  <a:tcPr anchor="ctr" marL="88900" marR="76200" marT="38100" marB="38100">
+                    <a:solidFill>
+                      <a:srgbClr val="FFFFFF"/>
+                    </a:solidFill>
+                  </a:tcPr>
+                </a:tc>
+              </a:tr>
+            </a:tbl>
+          </a:graphicData>
+        </a:graphic>
+      </p:graphicFrame>
+      <p:sp>
+        <p:nvSpPr>
+          <p:cNvPr id="7" name="Rounded Rectangle 6"/>
+          <p:cNvSpPr/>
+          <p:nvPr/>
+        </p:nvSpPr>
+        <p:spPr>
+          <a:xfrm>
+            <a:off x="4892040" y="4069080"/>
+            <a:ext cx="6812280" cy="1234440"/>
+          </a:xfrm>
+          <a:prstGeom prst="roundRect">
+            <a:avLst/>
+          </a:prstGeom>
+          <a:solidFill>
+            <a:srgbClr val="ECF3EE"/>
+          </a:solidFill>
+          <a:ln w="12700">
+            <a:solidFill>
+              <a:srgbClr val="BFD8C9"/>
+            </a:solidFill>
+          </a:ln>
+          <a:effectLst/>
+        </p:spPr>
+        <p:style>
+          <a:lnRef idx="1">
+            <a:schemeClr val="accent1"/>
+          </a:lnRef>
+          <a:fillRef idx="3">
+            <a:schemeClr val="accent1"/>
+          </a:fillRef>
+          <a:effectRef idx="2">
+            <a:schemeClr val="accent1"/>
+          </a:effectRef>
+          <a:fontRef idx="minor">
+            <a:schemeClr val="lt1"/>
+          </a:fontRef>
+        </p:style>
+        <p:txBody>
+          <a:bodyPr rtlCol="0" anchor="ctr" wrap="square" lIns="50800" rIns="50800" tIns="25400" bIns="25400"/>
+          <a:lstStyle/>
+          <a:p>
+            <a:pPr algn="ctr"/>
+            <a:r>
+              <a:rPr sz="1250" b="0">
+                <a:solidFill>
+                  <a:srgbClr val="1E5E3C"/>
+                </a:solidFill>
+                <a:latin typeface="Aptos"/>
+              </a:rPr>
+              <a:t>Scenario — multi-turn chat = long history + short new turn.</a:t>
+            </a:r>
+          </a:p>
+          <a:p>
+            <a:pPr algn="ctr"/>
+            <a:r>
+              <a:rPr sz="1250" b="0">
+                <a:solidFill>
+                  <a:srgbClr val="1E5E3C"/>
+                </a:solidFill>
+                <a:latin typeface="Aptos"/>
+              </a:rPr>
+              <a:t>Warm KV already sits in DECODE → force-decode the new turn in place (no move).</a:t>
+            </a:r>
+          </a:p>
+          <a:p>
+            <a:pPr algn="ctr"/>
+            <a:r>
+              <a:rPr sz="1250" b="0">
+                <a:solidFill>
+                  <a:srgbClr val="1E5E3C"/>
+                </a:solidFill>
+                <a:latin typeface="Aptos"/>
+              </a:rPr>
+              <a:t>Ship-to-prefill (A) only pays off when the NEW input is large.</a:t>
+            </a:r>
+          </a:p>
+        </p:txBody>
+      </p:sp>
+    </p:spTree>
+  </p:cSld>
+  <p:clrMapOvr>
+    <a:masterClrMapping/>
+  </p:clrMapOvr>
+</p:sld>
+</file>
+
+<file path=ppt/slides/slide6.xml><?xml version="1.0" encoding="utf-8"?>
+<p:sld xmlns:a="http://schemas.openxmlformats.org/drawingml/2006/main" xmlns:p="http://schemas.openxmlformats.org/presentationml/2006/main" xmlns:r="http://schemas.openxmlformats.org/officeDocument/2006/relationships">
+  <p:cSld>
+    <p:spTree>
+      <p:nvGrpSpPr>
+        <p:cNvPr id="1" name=""/>
+        <p:cNvGrpSpPr/>
+        <p:nvPr/>
+      </p:nvGrpSpPr>
+      <p:grpSpPr/>
+      <p:sp>
+        <p:nvSpPr>
+          <p:cNvPr id="2" name="Rectangle 1"/>
+          <p:cNvSpPr/>
+          <p:nvPr/>
+        </p:nvSpPr>
+        <p:spPr>
+          <a:xfrm>
+            <a:off x="0" y="0"/>
+            <a:ext cx="12191695" cy="868680"/>
+          </a:xfrm>
+          <a:prstGeom prst="rect">
+            <a:avLst/>
+          </a:prstGeom>
+          <a:solidFill>
+            <a:srgbClr val="1F3A5F"/>
+          </a:solidFill>
+          <a:ln>
+            <a:noFill/>
+          </a:ln>
+          <a:effectLst/>
+        </p:spPr>
+        <p:style>
+          <a:lnRef idx="1">
+            <a:schemeClr val="accent1"/>
+          </a:lnRef>
+          <a:fillRef idx="3">
+            <a:schemeClr val="accent1"/>
+          </a:fillRef>
+          <a:effectRef idx="2">
+            <a:schemeClr val="accent1"/>
+          </a:effectRef>
+          <a:fontRef idx="minor">
+            <a:schemeClr val="lt1"/>
+          </a:fontRef>
+        </p:style>
+        <p:txBody>
+          <a:bodyPr rtlCol="0" anchor="ctr"/>
+          <a:lstStyle/>
+          <a:p>
+            <a:pPr algn="ctr"/>
+          </a:p>
+        </p:txBody>
+      </p:sp>
+      <p:sp>
+        <p:nvSpPr>
+          <p:cNvPr id="3" name="TextBox 2"/>
+          <p:cNvSpPr txBox="1"/>
+          <p:nvPr/>
+        </p:nvSpPr>
+        <p:spPr>
+          <a:xfrm>
+            <a:off x="365760" y="109728"/>
+            <a:ext cx="11430000" cy="658368"/>
+          </a:xfrm>
+          <a:prstGeom prst="rect">
+            <a:avLst/>
+          </a:prstGeom>
+          <a:noFill/>
+        </p:spPr>
+        <p:txBody>
+          <a:bodyPr wrap="square">
+            <a:spAutoFit/>
+          </a:bodyPr>
+          <a:lstStyle/>
+          <a:p>
+            <a:r>
+              <a:rPr sz="2600" b="1">
+                <a:solidFill>
+                  <a:srgbClr val="FFFFFF"/>
+                </a:solidFill>
+                <a:latin typeface="Aptos"/>
+              </a:rPr>
               <a:t>Next steps</a:t>
             </a:r>
           </a:p>
@@ -7855,7 +8621,7 @@
 </p:sld>
 </file>
 
-<file path=ppt/slides/slide6.xml><?xml version="1.0" encoding="utf-8"?>
+<file path=ppt/slides/slide7.xml><?xml version="1.0" encoding="utf-8"?>
 <p:sld xmlns:a="http://schemas.openxmlformats.org/drawingml/2006/main" xmlns:p="http://schemas.openxmlformats.org/presentationml/2006/main" xmlns:r="http://schemas.openxmlformats.org/officeDocument/2006/relationships">
   <p:cSld>
     <p:spTree>

</xml_diff>